<commit_message>
Deck: correct portfolio unit total to 996 (physical occupancy 98.0%)
Slide 2's occupancy tile and the title-slide act card cited 985 total
units / 99.1% physical occupancy — those were stale figures. The
portfolio is 996 total units (14 out of service at Lears), 982 rentable,
976 occupied: 99.4% of rentable stock and 98.0% of all units.

Co-Authored-By: Claude Fable 5 <noreply@anthropic.com>
Claude-Session: https://claude.ai/code/session_01ES8jYhAoLjcAzwLMSJKcaQ
</commit_message>
<xml_diff>
--- a/docs/storeall-data-story-jul-2026.pptx
+++ b/docs/storeall-data-story-jul-2026.pptx
@@ -3471,7 +3471,7 @@
                 </a:solidFill>
                 <a:latin typeface="Arial"/>
               </a:rPr>
-              <a:t>We are sold out — 6 units left across 985.</a:t>
+              <a:t>We are sold out — 6 units left across 996.</a:t>
             </a:r>
           </a:p>
         </p:txBody>
@@ -9538,7 +9538,7 @@
                 </a:solidFill>
                 <a:latin typeface="Arial"/>
               </a:rPr>
-              <a:t>976 of 982 rentable units filled — physical occupancy 99.1% of all 985</a:t>
+              <a:t>976 of 982 rentable units filled — 98.0% of all 996 (14 out of service)</a:t>
             </a:r>
           </a:p>
         </p:txBody>

</xml_diff>